<commit_message>
slides: bloco de riscos no slide de dados e versao PDF para distribuicao
</commit_message>
<xml_diff>
--- a/reports/slides/nps_preditivo_fase1.pptx
+++ b/reports/slides/nps_preditivo_fase1.pptx
@@ -8326,6 +8326,38 @@
                 <a:latin typeface="Calibri"/>
               </a:rPr>
               <a:t>Janela de previsão: do registro do pedido até a pesquisa de NPS.</a:t>
+            </a:r>
+          </a:p>
+          <a:p>
+            <a:pPr algn="l">
+              <a:spcBef>
+                <a:spcPts val="1400"/>
+              </a:spcBef>
+            </a:pPr>
+            <a:r>
+              <a:rPr sz="1100" b="1">
+                <a:solidFill>
+                  <a:srgbClr val="ED145B"/>
+                </a:solidFill>
+                <a:latin typeface="Calibri"/>
+              </a:rPr>
+              <a:t>RISCOS DE USO INADEQUADO</a:t>
+            </a:r>
+          </a:p>
+          <a:p>
+            <a:pPr algn="l">
+              <a:spcBef>
+                <a:spcPts val="400"/>
+              </a:spcBef>
+            </a:pPr>
+            <a:r>
+              <a:rPr sz="1100" b="0">
+                <a:solidFill>
+                  <a:srgbClr val="1A1A1A"/>
+                </a:solidFill>
+                <a:latin typeface="Calibri"/>
+              </a:rPr>
+              <a:t>Leakage com csat_internal_score (não entra como preditor). Desbalanceamento 84% detratores (avaliado com precisão e recall, não só acurácia). Correlação ≠ causalidade nas recomendações operacionais.</a:t>
             </a:r>
           </a:p>
         </p:txBody>

</xml_diff>